<commit_message>
Add the Publisher Risk Monitor dashboard and a deck slide for it
- dashboard/build_dashboard.py builds a self-contained HTML page from the
  pipeline tables: per-publisher risk status ranked by commission on flagged
  orders, look-back control, signal mix, incrementality, and the journey
  before and after every click (domains only, no user ids or full URLs)
- Deck: new slide 10 with dashboard screenshots; recommendations point to it

Co-Authored-By: Claude Opus 5.5 <noreply@anthropic.com>
</commit_message>
<xml_diff>
--- a/deck/saatva_affiliate_analysis.pptx
+++ b/deck/saatva_affiliate_analysis.pptx
@@ -20,6 +20,7 @@
     <p:sldId id="265" r:id="rId17"/>
     <p:sldId id="266" r:id="rId18"/>
     <p:sldId id="267" r:id="rId19"/>
+    <p:sldId id="268" r:id="rId20"/>
   </p:sldIdLst>
   <p:sldSz cx="12191695" cy="6858000"/>
   <p:notesSz cx="6858000" cy="9144000"/>
@@ -586,7 +587,7 @@
           <a:lstStyle/>
           <a:p>
             <a:r>
-              <a:t>Full results table. Conservative estimates use the Walmart-calibrated factor for the mattress brands and the population ratio for Walmart.</a:t>
+              <a:t>The recommendations need a tool a partner manager can use every week, so the pipeline also builds one: dashboard/publisher_risk_monitor.html, a single file that opens in any browser. It re-scores every affiliate click under the chosen look-back window, so the 2-to-30-minute sensitivity is a click, not a footnote. It ranks publishers by the commission paid on their flagged orders, with a Hold, Review or OK status, and the average order and commission are inputs. Every number can be traced to the journey behind a click. The strip at the bottom is one of them: a shopper browsed Walmart, reached checkout, and two seconds after a Bizrate redirect an Impact click 'landed' on the order confirmation page, in the same second as the order. The publisher, impact:150372, has 32 credited orders in the panel, 78% of them from flagged clicks. The same view works for Saatva today; with Partnerize's own click and order logs instead of a one-day panel, the counts behind each status would be complete.</a:t>
             </a:r>
           </a:p>
         </p:txBody>
@@ -656,7 +657,7 @@
           <a:lstStyle/>
           <a:p>
             <a:r>
-              <a:t>Each check, what it found, and how the pipeline handles it.</a:t>
+              <a:t>Full results table. Conservative estimates use the Walmart-calibrated factor for the mattress brands and the population ratio for Walmart.</a:t>
             </a:r>
           </a:p>
         </p:txBody>
@@ -682,6 +683,76 @@
 </file>
 
 <file path=ppt/notesSlides/notesSlide12.xml><?xml version="1.0" encoding="utf-8"?>
+<p:notes xmlns:a="http://schemas.openxmlformats.org/drawingml/2006/main" xmlns:p="http://schemas.openxmlformats.org/presentationml/2006/main" xmlns:r="http://schemas.openxmlformats.org/officeDocument/2006/relationships">
+  <p:cSld>
+    <p:spTree>
+      <p:nvGrpSpPr>
+        <p:cNvPr id="1" name=""/>
+        <p:cNvGrpSpPr/>
+        <p:nvPr/>
+      </p:nvGrpSpPr>
+      <p:grpSpPr>
+        <a:xfrm>
+          <a:off x="0" y="0"/>
+          <a:ext cx="0" cy="0"/>
+          <a:chOff x="0" y="0"/>
+          <a:chExt cx="0" cy="0"/>
+        </a:xfrm>
+      </p:grpSpPr>
+      <p:sp>
+        <p:nvSpPr>
+          <p:cNvPr id="2" name="Slide Image Placeholder 1"/>
+          <p:cNvSpPr>
+            <a:spLocks noGrp="1"/>
+          </p:cNvSpPr>
+          <p:nvPr>
+            <p:ph type="sldImg" idx="2"/>
+          </p:nvPr>
+        </p:nvSpPr>
+        <p:spPr/>
+      </p:sp>
+      <p:sp>
+        <p:nvSpPr>
+          <p:cNvPr id="3" name="Notes Placeholder 2"/>
+          <p:cNvSpPr>
+            <a:spLocks noGrp="1"/>
+          </p:cNvSpPr>
+          <p:nvPr>
+            <p:ph type="body" idx="3" sz="quarter"/>
+          </p:nvPr>
+        </p:nvSpPr>
+        <p:spPr/>
+        <p:txBody>
+          <a:bodyPr/>
+          <a:lstStyle/>
+          <a:p>
+            <a:r>
+              <a:t>Each check, what it found, and how the pipeline handles it.</a:t>
+            </a:r>
+          </a:p>
+        </p:txBody>
+      </p:sp>
+      <p:sp>
+        <p:nvSpPr>
+          <p:cNvPr id="4" name="Slide Number Placeholder 3"/>
+          <p:cNvSpPr>
+            <a:spLocks noGrp="1"/>
+          </p:cNvSpPr>
+          <p:nvPr>
+            <p:ph type="sldNum" idx="5" sz="quarter"/>
+          </p:nvPr>
+        </p:nvSpPr>
+        <p:spPr/>
+      </p:sp>
+    </p:spTree>
+  </p:cSld>
+  <p:clrMapOvr>
+    <a:masterClrMapping/>
+  </p:clrMapOvr>
+</p:notes>
+</file>
+
+<file path=ppt/notesSlides/notesSlide13.xml><?xml version="1.0" encoding="utf-8"?>
 <p:notes xmlns:a="http://schemas.openxmlformats.org/drawingml/2006/main" xmlns:p="http://schemas.openxmlformats.org/presentationml/2006/main" xmlns:r="http://schemas.openxmlformats.org/officeDocument/2006/relationships">
   <p:cSld>
     <p:spTree>
@@ -4985,7 +5056,7 @@
                 </a:solidFill>
                 <a:latin typeface="Arial"/>
               </a:rPr>
-              <a:t>BACKUP</a:t>
+              <a:t>FROM ANALYSIS TO MONITORING</a:t>
             </a:r>
           </a:p>
         </p:txBody>
@@ -5027,7 +5098,7 @@
                 </a:solidFill>
                 <a:latin typeface="Georgia"/>
               </a:rPr>
-              <a:t>Results by brand</a:t>
+              <a:t>The indicators, built into a publisher monitor</a:t>
             </a:r>
           </a:p>
         </p:txBody>
@@ -5170,6 +5241,762 @@
                 <a:latin typeface="Arial"/>
               </a:rPr>
               <a:t>10</a:t>
+            </a:r>
+          </a:p>
+        </p:txBody>
+      </p:sp>
+      <p:pic>
+        <p:nvPicPr>
+          <p:cNvPr id="8" name="Picture 7" descr="dashboard_overview.png"/>
+          <p:cNvPicPr>
+            <a:picLocks noChangeAspect="1"/>
+          </p:cNvPicPr>
+          <p:nvPr/>
+        </p:nvPicPr>
+        <p:blipFill>
+          <a:blip r:embed="rId3"/>
+          <a:stretch>
+            <a:fillRect/>
+          </a:stretch>
+        </p:blipFill>
+        <p:spPr>
+          <a:xfrm>
+            <a:off x="548640" y="1463040"/>
+            <a:ext cx="5760720" cy="3577947"/>
+          </a:xfrm>
+          <a:prstGeom prst="rect">
+            <a:avLst/>
+          </a:prstGeom>
+        </p:spPr>
+      </p:pic>
+      <p:sp>
+        <p:nvSpPr>
+          <p:cNvPr id="9" name="Rectangle 8"/>
+          <p:cNvSpPr/>
+          <p:nvPr/>
+        </p:nvSpPr>
+        <p:spPr>
+          <a:xfrm>
+            <a:off x="548640" y="1463040"/>
+            <a:ext cx="5760720" cy="3577947"/>
+          </a:xfrm>
+          <a:prstGeom prst="rect">
+            <a:avLst/>
+          </a:prstGeom>
+          <a:noFill/>
+          <a:ln w="9525">
+            <a:solidFill>
+              <a:srgbClr val="E3E8EE"/>
+            </a:solidFill>
+          </a:ln>
+        </p:spPr>
+        <p:txBody>
+          <a:bodyPr rtlCol="0" anchor="ctr"/>
+          <a:lstStyle/>
+          <a:p>
+            <a:pPr algn="ctr"/>
+          </a:p>
+        </p:txBody>
+      </p:sp>
+      <p:sp>
+        <p:nvSpPr>
+          <p:cNvPr id="10" name="Oval 9"/>
+          <p:cNvSpPr/>
+          <p:nvPr/>
+        </p:nvSpPr>
+        <p:spPr>
+          <a:xfrm>
+            <a:off x="6675120" y="1554480"/>
+            <a:ext cx="329184" cy="329184"/>
+          </a:xfrm>
+          <a:prstGeom prst="ellipse">
+            <a:avLst/>
+          </a:prstGeom>
+          <a:solidFill>
+            <a:srgbClr val="FF9438"/>
+          </a:solidFill>
+          <a:ln>
+            <a:noFill/>
+          </a:ln>
+        </p:spPr>
+        <p:txBody>
+          <a:bodyPr rtlCol="0" anchor="ctr" wrap="square" lIns="0" rIns="0" tIns="18288" bIns="18288">
+            <a:noAutofit/>
+          </a:bodyPr>
+          <a:lstStyle/>
+          <a:p>
+            <a:pPr algn="ctr">
+              <a:lnSpc>
+                <a:spcPct val="110000"/>
+              </a:lnSpc>
+              <a:spcAft>
+                <a:spcPts val="0"/>
+              </a:spcAft>
+            </a:pPr>
+            <a:r>
+              <a:rPr sz="1200" i="0" b="1">
+                <a:solidFill>
+                  <a:srgbClr val="FFFFFF"/>
+                </a:solidFill>
+                <a:latin typeface="Arial"/>
+              </a:rPr>
+              <a:t>1</a:t>
+            </a:r>
+          </a:p>
+        </p:txBody>
+      </p:sp>
+      <p:sp>
+        <p:nvSpPr>
+          <p:cNvPr id="11" name="TextBox 10"/>
+          <p:cNvSpPr txBox="1"/>
+          <p:nvPr/>
+        </p:nvSpPr>
+        <p:spPr>
+          <a:xfrm>
+            <a:off x="7150608" y="1536192"/>
+            <a:ext cx="4492447" cy="292608"/>
+          </a:xfrm>
+          <a:prstGeom prst="rect">
+            <a:avLst/>
+          </a:prstGeom>
+          <a:noFill/>
+        </p:spPr>
+        <p:txBody>
+          <a:bodyPr wrap="square" lIns="0" rIns="0" tIns="0" bIns="0" anchor="t">
+            <a:noAutofit/>
+          </a:bodyPr>
+          <a:lstStyle/>
+          <a:p>
+            <a:pPr algn="l">
+              <a:lnSpc>
+                <a:spcPct val="110000"/>
+              </a:lnSpc>
+              <a:spcAft>
+                <a:spcPts val="0"/>
+              </a:spcAft>
+            </a:pPr>
+            <a:r>
+              <a:rPr sz="1500" i="0" b="1">
+                <a:solidFill>
+                  <a:srgbClr val="0B2A4A"/>
+                </a:solidFill>
+                <a:latin typeface="Arial"/>
+              </a:rPr>
+              <a:t>Any look-back, one click</a:t>
+            </a:r>
+          </a:p>
+        </p:txBody>
+      </p:sp>
+      <p:sp>
+        <p:nvSpPr>
+          <p:cNvPr id="12" name="TextBox 11"/>
+          <p:cNvSpPr txBox="1"/>
+          <p:nvPr/>
+        </p:nvSpPr>
+        <p:spPr>
+          <a:xfrm>
+            <a:off x="7150608" y="1856231"/>
+            <a:ext cx="4492447" cy="685800"/>
+          </a:xfrm>
+          <a:prstGeom prst="rect">
+            <a:avLst/>
+          </a:prstGeom>
+          <a:noFill/>
+        </p:spPr>
+        <p:txBody>
+          <a:bodyPr wrap="square" lIns="0" rIns="0" tIns="0" bIns="0" anchor="t">
+            <a:noAutofit/>
+          </a:bodyPr>
+          <a:lstStyle/>
+          <a:p>
+            <a:pPr algn="l">
+              <a:lnSpc>
+                <a:spcPct val="105000"/>
+              </a:lnSpc>
+              <a:spcAft>
+                <a:spcPts val="0"/>
+              </a:spcAft>
+            </a:pPr>
+            <a:r>
+              <a:rPr sz="1250" i="0" b="0">
+                <a:solidFill>
+                  <a:srgbClr val="647282"/>
+                </a:solidFill>
+                <a:latin typeface="Arial"/>
+              </a:rPr>
+              <a:t>Every click re-scored at 2, 10 or 30 minutes; the sensitivity test becomes a control</a:t>
+            </a:r>
+          </a:p>
+        </p:txBody>
+      </p:sp>
+      <p:sp>
+        <p:nvSpPr>
+          <p:cNvPr id="13" name="Oval 12"/>
+          <p:cNvSpPr/>
+          <p:nvPr/>
+        </p:nvSpPr>
+        <p:spPr>
+          <a:xfrm>
+            <a:off x="6675120" y="2697480"/>
+            <a:ext cx="329184" cy="329184"/>
+          </a:xfrm>
+          <a:prstGeom prst="ellipse">
+            <a:avLst/>
+          </a:prstGeom>
+          <a:solidFill>
+            <a:srgbClr val="FF9438"/>
+          </a:solidFill>
+          <a:ln>
+            <a:noFill/>
+          </a:ln>
+        </p:spPr>
+        <p:txBody>
+          <a:bodyPr rtlCol="0" anchor="ctr" wrap="square" lIns="0" rIns="0" tIns="18288" bIns="18288">
+            <a:noAutofit/>
+          </a:bodyPr>
+          <a:lstStyle/>
+          <a:p>
+            <a:pPr algn="ctr">
+              <a:lnSpc>
+                <a:spcPct val="110000"/>
+              </a:lnSpc>
+              <a:spcAft>
+                <a:spcPts val="0"/>
+              </a:spcAft>
+            </a:pPr>
+            <a:r>
+              <a:rPr sz="1200" i="0" b="1">
+                <a:solidFill>
+                  <a:srgbClr val="FFFFFF"/>
+                </a:solidFill>
+                <a:latin typeface="Arial"/>
+              </a:rPr>
+              <a:t>2</a:t>
+            </a:r>
+          </a:p>
+        </p:txBody>
+      </p:sp>
+      <p:sp>
+        <p:nvSpPr>
+          <p:cNvPr id="14" name="TextBox 13"/>
+          <p:cNvSpPr txBox="1"/>
+          <p:nvPr/>
+        </p:nvSpPr>
+        <p:spPr>
+          <a:xfrm>
+            <a:off x="7150608" y="2679192"/>
+            <a:ext cx="4492447" cy="292608"/>
+          </a:xfrm>
+          <a:prstGeom prst="rect">
+            <a:avLst/>
+          </a:prstGeom>
+          <a:noFill/>
+        </p:spPr>
+        <p:txBody>
+          <a:bodyPr wrap="square" lIns="0" rIns="0" tIns="0" bIns="0" anchor="t">
+            <a:noAutofit/>
+          </a:bodyPr>
+          <a:lstStyle/>
+          <a:p>
+            <a:pPr algn="l">
+              <a:lnSpc>
+                <a:spcPct val="110000"/>
+              </a:lnSpc>
+              <a:spcAft>
+                <a:spcPts val="0"/>
+              </a:spcAft>
+            </a:pPr>
+            <a:r>
+              <a:rPr sz="1500" i="0" b="1">
+                <a:solidFill>
+                  <a:srgbClr val="0B2A4A"/>
+                </a:solidFill>
+                <a:latin typeface="Arial"/>
+              </a:rPr>
+              <a:t>Ranked by money, with a status</a:t>
+            </a:r>
+          </a:p>
+        </p:txBody>
+      </p:sp>
+      <p:sp>
+        <p:nvSpPr>
+          <p:cNvPr id="15" name="TextBox 14"/>
+          <p:cNvSpPr txBox="1"/>
+          <p:nvPr/>
+        </p:nvSpPr>
+        <p:spPr>
+          <a:xfrm>
+            <a:off x="7150608" y="2999232"/>
+            <a:ext cx="4492447" cy="685800"/>
+          </a:xfrm>
+          <a:prstGeom prst="rect">
+            <a:avLst/>
+          </a:prstGeom>
+          <a:noFill/>
+        </p:spPr>
+        <p:txBody>
+          <a:bodyPr wrap="square" lIns="0" rIns="0" tIns="0" bIns="0" anchor="t">
+            <a:noAutofit/>
+          </a:bodyPr>
+          <a:lstStyle/>
+          <a:p>
+            <a:pPr algn="l">
+              <a:lnSpc>
+                <a:spcPct val="105000"/>
+              </a:lnSpc>
+              <a:spcAft>
+                <a:spcPts val="0"/>
+              </a:spcAft>
+            </a:pPr>
+            <a:r>
+              <a:rPr sz="1250" i="0" b="0">
+                <a:solidFill>
+                  <a:srgbClr val="647282"/>
+                </a:solidFill>
+                <a:latin typeface="Arial"/>
+              </a:rPr>
+              <a:t>Hold, Review or OK per publisher, by commission on flagged orders; AOV and rate are inputs</a:t>
+            </a:r>
+          </a:p>
+        </p:txBody>
+      </p:sp>
+      <p:sp>
+        <p:nvSpPr>
+          <p:cNvPr id="16" name="Oval 15"/>
+          <p:cNvSpPr/>
+          <p:nvPr/>
+        </p:nvSpPr>
+        <p:spPr>
+          <a:xfrm>
+            <a:off x="6675120" y="3840480"/>
+            <a:ext cx="329184" cy="329184"/>
+          </a:xfrm>
+          <a:prstGeom prst="ellipse">
+            <a:avLst/>
+          </a:prstGeom>
+          <a:solidFill>
+            <a:srgbClr val="FF9438"/>
+          </a:solidFill>
+          <a:ln>
+            <a:noFill/>
+          </a:ln>
+        </p:spPr>
+        <p:txBody>
+          <a:bodyPr rtlCol="0" anchor="ctr" wrap="square" lIns="0" rIns="0" tIns="18288" bIns="18288">
+            <a:noAutofit/>
+          </a:bodyPr>
+          <a:lstStyle/>
+          <a:p>
+            <a:pPr algn="ctr">
+              <a:lnSpc>
+                <a:spcPct val="110000"/>
+              </a:lnSpc>
+              <a:spcAft>
+                <a:spcPts val="0"/>
+              </a:spcAft>
+            </a:pPr>
+            <a:r>
+              <a:rPr sz="1200" i="0" b="1">
+                <a:solidFill>
+                  <a:srgbClr val="FFFFFF"/>
+                </a:solidFill>
+                <a:latin typeface="Arial"/>
+              </a:rPr>
+              <a:t>3</a:t>
+            </a:r>
+          </a:p>
+        </p:txBody>
+      </p:sp>
+      <p:sp>
+        <p:nvSpPr>
+          <p:cNvPr id="17" name="TextBox 16"/>
+          <p:cNvSpPr txBox="1"/>
+          <p:nvPr/>
+        </p:nvSpPr>
+        <p:spPr>
+          <a:xfrm>
+            <a:off x="7150608" y="3822192"/>
+            <a:ext cx="4492447" cy="292608"/>
+          </a:xfrm>
+          <a:prstGeom prst="rect">
+            <a:avLst/>
+          </a:prstGeom>
+          <a:noFill/>
+        </p:spPr>
+        <p:txBody>
+          <a:bodyPr wrap="square" lIns="0" rIns="0" tIns="0" bIns="0" anchor="t">
+            <a:noAutofit/>
+          </a:bodyPr>
+          <a:lstStyle/>
+          <a:p>
+            <a:pPr algn="l">
+              <a:lnSpc>
+                <a:spcPct val="110000"/>
+              </a:lnSpc>
+              <a:spcAft>
+                <a:spcPts val="0"/>
+              </a:spcAft>
+            </a:pPr>
+            <a:r>
+              <a:rPr sz="1500" i="0" b="1">
+                <a:solidFill>
+                  <a:srgbClr val="0B2A4A"/>
+                </a:solidFill>
+                <a:latin typeface="Arial"/>
+              </a:rPr>
+              <a:t>Every flag has a journey</a:t>
+            </a:r>
+          </a:p>
+        </p:txBody>
+      </p:sp>
+      <p:sp>
+        <p:nvSpPr>
+          <p:cNvPr id="18" name="TextBox 17"/>
+          <p:cNvSpPr txBox="1"/>
+          <p:nvPr/>
+        </p:nvSpPr>
+        <p:spPr>
+          <a:xfrm>
+            <a:off x="7150608" y="4142232"/>
+            <a:ext cx="4492447" cy="685800"/>
+          </a:xfrm>
+          <a:prstGeom prst="rect">
+            <a:avLst/>
+          </a:prstGeom>
+          <a:noFill/>
+        </p:spPr>
+        <p:txBody>
+          <a:bodyPr wrap="square" lIns="0" rIns="0" tIns="0" bIns="0" anchor="t">
+            <a:noAutofit/>
+          </a:bodyPr>
+          <a:lstStyle/>
+          <a:p>
+            <a:pPr algn="l">
+              <a:lnSpc>
+                <a:spcPct val="105000"/>
+              </a:lnSpc>
+              <a:spcAft>
+                <a:spcPts val="0"/>
+              </a:spcAft>
+            </a:pPr>
+            <a:r>
+              <a:rPr sz="1250" i="0" b="0">
+                <a:solidFill>
+                  <a:srgbClr val="647282"/>
+                </a:solidFill>
+                <a:latin typeface="Arial"/>
+              </a:rPr>
+              <a:t>The sites before and after each click, so a reviewer sees the evidence, not a score</a:t>
+            </a:r>
+          </a:p>
+        </p:txBody>
+      </p:sp>
+      <p:sp>
+        <p:nvSpPr>
+          <p:cNvPr id="19" name="TextBox 18"/>
+          <p:cNvSpPr txBox="1"/>
+          <p:nvPr/>
+        </p:nvSpPr>
+        <p:spPr>
+          <a:xfrm>
+            <a:off x="548640" y="5166360"/>
+            <a:ext cx="11094415" cy="256032"/>
+          </a:xfrm>
+          <a:prstGeom prst="rect">
+            <a:avLst/>
+          </a:prstGeom>
+          <a:noFill/>
+        </p:spPr>
+        <p:txBody>
+          <a:bodyPr wrap="square" lIns="0" rIns="0" tIns="0" bIns="0" anchor="t">
+            <a:noAutofit/>
+          </a:bodyPr>
+          <a:lstStyle/>
+          <a:p>
+            <a:pPr algn="l">
+              <a:lnSpc>
+                <a:spcPct val="110000"/>
+              </a:lnSpc>
+              <a:spcAft>
+                <a:spcPts val="0"/>
+              </a:spcAft>
+            </a:pPr>
+            <a:r>
+              <a:rPr sz="1200" i="0" b="1">
+                <a:solidFill>
+                  <a:srgbClr val="647282"/>
+                </a:solidFill>
+                <a:latin typeface="Arial"/>
+              </a:rPr>
+              <a:t>One of impact:150372's 32 orders: the click "lands" on the order confirmation page</a:t>
+            </a:r>
+          </a:p>
+        </p:txBody>
+      </p:sp>
+      <p:pic>
+        <p:nvPicPr>
+          <p:cNvPr id="20" name="Picture 19" descr="dashboard_journey.png"/>
+          <p:cNvPicPr>
+            <a:picLocks noChangeAspect="1"/>
+          </p:cNvPicPr>
+          <p:nvPr/>
+        </p:nvPicPr>
+        <p:blipFill>
+          <a:blip r:embed="rId4"/>
+          <a:stretch>
+            <a:fillRect/>
+          </a:stretch>
+        </p:blipFill>
+        <p:spPr>
+          <a:xfrm>
+            <a:off x="548640" y="5458968"/>
+            <a:ext cx="9430252" cy="733006"/>
+          </a:xfrm>
+          <a:prstGeom prst="rect">
+            <a:avLst/>
+          </a:prstGeom>
+        </p:spPr>
+      </p:pic>
+    </p:spTree>
+  </p:cSld>
+  <p:clrMapOvr>
+    <a:masterClrMapping/>
+  </p:clrMapOvr>
+</p:sld>
+</file>
+
+<file path=ppt/slides/slide11.xml><?xml version="1.0" encoding="utf-8"?>
+<p:sld xmlns:a="http://schemas.openxmlformats.org/drawingml/2006/main" xmlns:p="http://schemas.openxmlformats.org/presentationml/2006/main" xmlns:r="http://schemas.openxmlformats.org/officeDocument/2006/relationships">
+  <p:cSld>
+    <p:spTree>
+      <p:nvGrpSpPr>
+        <p:cNvPr id="1" name=""/>
+        <p:cNvGrpSpPr/>
+        <p:nvPr/>
+      </p:nvGrpSpPr>
+      <p:grpSpPr/>
+      <p:sp>
+        <p:nvSpPr>
+          <p:cNvPr id="2" name="TextBox 1"/>
+          <p:cNvSpPr txBox="1"/>
+          <p:nvPr/>
+        </p:nvSpPr>
+        <p:spPr>
+          <a:xfrm>
+            <a:off x="548640" y="384048"/>
+            <a:ext cx="9144000" cy="274320"/>
+          </a:xfrm>
+          <a:prstGeom prst="rect">
+            <a:avLst/>
+          </a:prstGeom>
+          <a:noFill/>
+        </p:spPr>
+        <p:txBody>
+          <a:bodyPr wrap="square" lIns="0" rIns="0" tIns="0" bIns="0" anchor="t">
+            <a:noAutofit/>
+          </a:bodyPr>
+          <a:lstStyle/>
+          <a:p>
+            <a:pPr algn="l">
+              <a:lnSpc>
+                <a:spcPct val="110000"/>
+              </a:lnSpc>
+              <a:spcAft>
+                <a:spcPts val="0"/>
+              </a:spcAft>
+            </a:pPr>
+            <a:r>
+              <a:rPr sz="1100" i="0" b="1" spc="150">
+                <a:solidFill>
+                  <a:srgbClr val="C9620E"/>
+                </a:solidFill>
+                <a:latin typeface="Arial"/>
+              </a:rPr>
+              <a:t>BACKUP</a:t>
+            </a:r>
+          </a:p>
+        </p:txBody>
+      </p:sp>
+      <p:sp>
+        <p:nvSpPr>
+          <p:cNvPr id="3" name="TextBox 2"/>
+          <p:cNvSpPr txBox="1"/>
+          <p:nvPr/>
+        </p:nvSpPr>
+        <p:spPr>
+          <a:xfrm>
+            <a:off x="548640" y="658368"/>
+            <a:ext cx="11094415" cy="685800"/>
+          </a:xfrm>
+          <a:prstGeom prst="rect">
+            <a:avLst/>
+          </a:prstGeom>
+          <a:noFill/>
+        </p:spPr>
+        <p:txBody>
+          <a:bodyPr wrap="square" lIns="0" rIns="0" tIns="0" bIns="0" anchor="t">
+            <a:noAutofit/>
+          </a:bodyPr>
+          <a:lstStyle/>
+          <a:p>
+            <a:pPr algn="l">
+              <a:lnSpc>
+                <a:spcPct val="100000"/>
+              </a:lnSpc>
+              <a:spcAft>
+                <a:spcPts val="0"/>
+              </a:spcAft>
+            </a:pPr>
+            <a:r>
+              <a:rPr sz="3200" i="0" b="0">
+                <a:solidFill>
+                  <a:srgbClr val="0B2A4A"/>
+                </a:solidFill>
+                <a:latin typeface="Georgia"/>
+              </a:rPr>
+              <a:t>Results by brand</a:t>
+            </a:r>
+          </a:p>
+        </p:txBody>
+      </p:sp>
+      <p:sp>
+        <p:nvSpPr>
+          <p:cNvPr id="4" name="TextBox 3"/>
+          <p:cNvSpPr txBox="1"/>
+          <p:nvPr/>
+        </p:nvSpPr>
+        <p:spPr>
+          <a:xfrm>
+            <a:off x="548640" y="6419088"/>
+            <a:ext cx="8229600" cy="228600"/>
+          </a:xfrm>
+          <a:prstGeom prst="rect">
+            <a:avLst/>
+          </a:prstGeom>
+          <a:noFill/>
+        </p:spPr>
+        <p:txBody>
+          <a:bodyPr wrap="square" lIns="0" rIns="0" tIns="0" bIns="0" anchor="t">
+            <a:noAutofit/>
+          </a:bodyPr>
+          <a:lstStyle/>
+          <a:p>
+            <a:pPr algn="l">
+              <a:lnSpc>
+                <a:spcPct val="110000"/>
+              </a:lnSpc>
+              <a:spcAft>
+                <a:spcPts val="0"/>
+              </a:spcAft>
+            </a:pPr>
+            <a:r>
+              <a:rPr sz="900" i="0" b="0">
+                <a:solidFill>
+                  <a:srgbClr val="647282"/>
+                </a:solidFill>
+                <a:latin typeface="Arial"/>
+              </a:rPr>
+              <a:t>Saatva affiliate analysis  ·  Hagay Gross</a:t>
+            </a:r>
+          </a:p>
+        </p:txBody>
+      </p:sp>
+      <p:sp>
+        <p:nvSpPr>
+          <p:cNvPr id="5" name="Oval 4"/>
+          <p:cNvSpPr/>
+          <p:nvPr/>
+        </p:nvSpPr>
+        <p:spPr>
+          <a:xfrm>
+            <a:off x="11185855" y="6460236"/>
+            <a:ext cx="128016" cy="128016"/>
+          </a:xfrm>
+          <a:prstGeom prst="ellipse">
+            <a:avLst/>
+          </a:prstGeom>
+          <a:solidFill>
+            <a:srgbClr val="FF9438"/>
+          </a:solidFill>
+          <a:ln>
+            <a:noFill/>
+          </a:ln>
+        </p:spPr>
+        <p:txBody>
+          <a:bodyPr rtlCol="0" anchor="ctr"/>
+          <a:lstStyle/>
+          <a:p>
+            <a:pPr algn="ctr"/>
+          </a:p>
+        </p:txBody>
+      </p:sp>
+      <p:sp>
+        <p:nvSpPr>
+          <p:cNvPr id="6" name="Oval 5"/>
+          <p:cNvSpPr/>
+          <p:nvPr/>
+        </p:nvSpPr>
+        <p:spPr>
+          <a:xfrm>
+            <a:off x="11268151" y="6460236"/>
+            <a:ext cx="128016" cy="128016"/>
+          </a:xfrm>
+          <a:prstGeom prst="ellipse">
+            <a:avLst/>
+          </a:prstGeom>
+          <a:solidFill>
+            <a:srgbClr val="368EF8"/>
+          </a:solidFill>
+          <a:ln>
+            <a:noFill/>
+          </a:ln>
+        </p:spPr>
+        <p:txBody>
+          <a:bodyPr rtlCol="0" anchor="ctr"/>
+          <a:lstStyle/>
+          <a:p>
+            <a:pPr algn="ctr"/>
+          </a:p>
+        </p:txBody>
+      </p:sp>
+      <p:sp>
+        <p:nvSpPr>
+          <p:cNvPr id="7" name="TextBox 6"/>
+          <p:cNvSpPr txBox="1"/>
+          <p:nvPr/>
+        </p:nvSpPr>
+        <p:spPr>
+          <a:xfrm>
+            <a:off x="11441887" y="6419088"/>
+            <a:ext cx="201168" cy="228600"/>
+          </a:xfrm>
+          <a:prstGeom prst="rect">
+            <a:avLst/>
+          </a:prstGeom>
+          <a:noFill/>
+        </p:spPr>
+        <p:txBody>
+          <a:bodyPr wrap="square" lIns="0" rIns="0" tIns="0" bIns="0" anchor="t">
+            <a:noAutofit/>
+          </a:bodyPr>
+          <a:lstStyle/>
+          <a:p>
+            <a:pPr algn="r">
+              <a:lnSpc>
+                <a:spcPct val="110000"/>
+              </a:lnSpc>
+              <a:spcAft>
+                <a:spcPts val="0"/>
+              </a:spcAft>
+            </a:pPr>
+            <a:r>
+              <a:rPr sz="900" i="0" b="0">
+                <a:solidFill>
+                  <a:srgbClr val="647282"/>
+                </a:solidFill>
+                <a:latin typeface="Arial"/>
+              </a:rPr>
+              <a:t>11</a:t>
             </a:r>
           </a:p>
         </p:txBody>
@@ -7684,7 +8511,7 @@
 </p:sld>
 </file>
 
-<file path=ppt/slides/slide11.xml><?xml version="1.0" encoding="utf-8"?>
+<file path=ppt/slides/slide12.xml><?xml version="1.0" encoding="utf-8"?>
 <p:sld xmlns:a="http://schemas.openxmlformats.org/drawingml/2006/main" xmlns:p="http://schemas.openxmlformats.org/presentationml/2006/main" xmlns:r="http://schemas.openxmlformats.org/officeDocument/2006/relationships">
   <p:cSld>
     <p:spTree>
@@ -7915,7 +8742,7 @@
                 </a:solidFill>
                 <a:latin typeface="Arial"/>
               </a:rPr>
-              <a:t>11</a:t>
+              <a:t>12</a:t>
             </a:r>
           </a:p>
         </p:txBody>
@@ -9021,7 +9848,7 @@
 </p:sld>
 </file>
 
-<file path=ppt/slides/slide12.xml><?xml version="1.0" encoding="utf-8"?>
+<file path=ppt/slides/slide13.xml><?xml version="1.0" encoding="utf-8"?>
 <p:sld xmlns:a="http://schemas.openxmlformats.org/drawingml/2006/main" xmlns:p="http://schemas.openxmlformats.org/presentationml/2006/main" xmlns:r="http://schemas.openxmlformats.org/officeDocument/2006/relationships">
   <p:cSld>
     <p:spTree>
@@ -9252,7 +10079,7 @@
                 </a:solidFill>
                 <a:latin typeface="Arial"/>
               </a:rPr>
-              <a:t>12</a:t>
+              <a:t>13</a:t>
             </a:r>
           </a:p>
         </p:txBody>
@@ -23406,7 +24233,7 @@
                 </a:solidFill>
                 <a:latin typeface="Arial"/>
               </a:rPr>
-              <a:t>Plus extension stand-down and a PPC and trademark policy</a:t>
+              <a:t>Cart-stage clicks add no orders (slide 7); plus extension stand-down, PPC policy</a:t>
             </a:r>
           </a:p>
         </p:txBody>
@@ -23495,7 +24322,7 @@
                 </a:solidFill>
                 <a:latin typeface="Arial"/>
               </a:rPr>
-              <a:t>Monitor six indicators per publisher</a:t>
+              <a:t>Monitor every publisher (built: next slide)</a:t>
             </a:r>
           </a:p>
         </p:txBody>

</xml_diff>

<commit_message>
Redesign the dashboard in the Platform Elements look; drop on-page fine print
- Geekblue/antd styling: section bands, metric cards, underline brand tabs,
  pill look-back control, .pe-table tables, purple/gold series
- Caveats and definitions moved from footnotes into info tooltips
- Signals as a table; drill-down paged with 'Show more'
- Deck slide 10 screenshots refreshed

Co-Authored-By: Claude Opus 5.5 <noreply@anthropic.com>
</commit_message>
<xml_diff>
--- a/deck/saatva_affiliate_analysis.pptx
+++ b/deck/saatva_affiliate_analysis.pptx
@@ -5262,7 +5262,7 @@
         <p:spPr>
           <a:xfrm>
             <a:off x="548640" y="1463040"/>
-            <a:ext cx="5760720" cy="3577947"/>
+            <a:ext cx="5394960" cy="3624739"/>
           </a:xfrm>
           <a:prstGeom prst="rect">
             <a:avLst/>
@@ -5278,7 +5278,7 @@
         <p:spPr>
           <a:xfrm>
             <a:off x="548640" y="1463040"/>
-            <a:ext cx="5760720" cy="3577947"/>
+            <a:ext cx="5394960" cy="3624738"/>
           </a:xfrm>
           <a:prstGeom prst="rect">
             <a:avLst/>
@@ -5306,7 +5306,7 @@
         </p:nvSpPr>
         <p:spPr>
           <a:xfrm>
-            <a:off x="6675120" y="1554480"/>
+            <a:off x="6400800" y="1554480"/>
             <a:ext cx="329184" cy="329184"/>
           </a:xfrm>
           <a:prstGeom prst="ellipse">
@@ -5353,8 +5353,8 @@
         </p:nvSpPr>
         <p:spPr>
           <a:xfrm>
-            <a:off x="7150608" y="1536192"/>
-            <a:ext cx="4492447" cy="292608"/>
+            <a:off x="6876288" y="1536192"/>
+            <a:ext cx="4766767" cy="292608"/>
           </a:xfrm>
           <a:prstGeom prst="rect">
             <a:avLst/>
@@ -5395,8 +5395,8 @@
         </p:nvSpPr>
         <p:spPr>
           <a:xfrm>
-            <a:off x="7150608" y="1856231"/>
-            <a:ext cx="4492447" cy="685800"/>
+            <a:off x="6876288" y="1856231"/>
+            <a:ext cx="4766767" cy="685800"/>
           </a:xfrm>
           <a:prstGeom prst="rect">
             <a:avLst/>
@@ -5437,7 +5437,7 @@
         </p:nvSpPr>
         <p:spPr>
           <a:xfrm>
-            <a:off x="6675120" y="2697480"/>
+            <a:off x="6400800" y="2697480"/>
             <a:ext cx="329184" cy="329184"/>
           </a:xfrm>
           <a:prstGeom prst="ellipse">
@@ -5484,8 +5484,8 @@
         </p:nvSpPr>
         <p:spPr>
           <a:xfrm>
-            <a:off x="7150608" y="2679192"/>
-            <a:ext cx="4492447" cy="292608"/>
+            <a:off x="6876288" y="2679192"/>
+            <a:ext cx="4766767" cy="292608"/>
           </a:xfrm>
           <a:prstGeom prst="rect">
             <a:avLst/>
@@ -5526,8 +5526,8 @@
         </p:nvSpPr>
         <p:spPr>
           <a:xfrm>
-            <a:off x="7150608" y="2999232"/>
-            <a:ext cx="4492447" cy="685800"/>
+            <a:off x="6876288" y="2999232"/>
+            <a:ext cx="4766767" cy="685800"/>
           </a:xfrm>
           <a:prstGeom prst="rect">
             <a:avLst/>
@@ -5568,7 +5568,7 @@
         </p:nvSpPr>
         <p:spPr>
           <a:xfrm>
-            <a:off x="6675120" y="3840480"/>
+            <a:off x="6400800" y="3840480"/>
             <a:ext cx="329184" cy="329184"/>
           </a:xfrm>
           <a:prstGeom prst="ellipse">
@@ -5615,8 +5615,8 @@
         </p:nvSpPr>
         <p:spPr>
           <a:xfrm>
-            <a:off x="7150608" y="3822192"/>
-            <a:ext cx="4492447" cy="292608"/>
+            <a:off x="6876288" y="3822192"/>
+            <a:ext cx="4766767" cy="292608"/>
           </a:xfrm>
           <a:prstGeom prst="rect">
             <a:avLst/>
@@ -5657,8 +5657,8 @@
         </p:nvSpPr>
         <p:spPr>
           <a:xfrm>
-            <a:off x="7150608" y="4142232"/>
-            <a:ext cx="4492447" cy="685800"/>
+            <a:off x="6876288" y="4142232"/>
+            <a:ext cx="4766767" cy="685800"/>
           </a:xfrm>
           <a:prstGeom prst="rect">
             <a:avLst/>
@@ -5699,7 +5699,7 @@
         </p:nvSpPr>
         <p:spPr>
           <a:xfrm>
-            <a:off x="548640" y="5166360"/>
+            <a:off x="548640" y="5230368"/>
             <a:ext cx="11094415" cy="256032"/>
           </a:xfrm>
           <a:prstGeom prst="rect">
@@ -5749,8 +5749,8 @@
         </p:blipFill>
         <p:spPr>
           <a:xfrm>
-            <a:off x="548640" y="5458968"/>
-            <a:ext cx="9430252" cy="733006"/>
+            <a:off x="548640" y="5522976"/>
+            <a:ext cx="9430252" cy="697646"/>
           </a:xfrm>
           <a:prstGeom prst="rect">
             <a:avLst/>

</xml_diff>

<commit_message>
Add seasonality check: move the scale factors from August to 1 May with Google Trends
Mattress search interest around 1 May is 1.5-2.8x the August average, so the
August-calibrated factor understates that day (~2x; Saatva ~33K vs 16.7K
clicks/day). Walmart moves -4%. Kept as a sensitivity; the caveat that August
overstates May was the wrong way round and is corrected in README, SQL and deck.

Co-Authored-By: Claude Opus 5.5 <noreply@anthropic.com>
</commit_message>
<xml_diff>
--- a/deck/saatva_affiliate_analysis.pptx
+++ b/deck/saatva_affiliate_analysis.pptx
@@ -1077,7 +1077,7 @@
           <a:lstStyle/>
           <a:p>
             <a:r>
-              <a:t>Validation changed the answer. 14.7% of rows were exact duplicates, and some people were recorded under two user ids, one a partial copy of the other; left as is, that inflated brand visits by 14–28% and orders by 20%. I merged ids that share three or more identical events. One pass selects the users who touched any of the five brands, so everything runs on 3.4% of the data, in about 30 seconds. Scaling: a factor calibrated on walmart.com recovers only 35–50% of the mattress sites' Similarweb traffic, because the panel under-covers that audience. The mattress brands therefore use a factor calibrated on the mattress sites themselves, which reproduces each brand within 0.89–1.27×. Caveat: Similarweb's latest public month is August, the Labor Day sale season.</a:t>
+              <a:t>Validation changed the answer. 14.7% of rows were exact duplicates, and some people were recorded under two user ids, one a partial copy of the other; left as is, that inflated brand visits by 14–28% and orders by 20%. I merged ids that share three or more identical events. One pass selects the users who touched any of the five brands, so everything runs on 3.4% of the data, in about 30 seconds. Scaling: a factor calibrated on walmart.com recovers only 35–50% of the mattress sites' Similarweb traffic, because the panel under-covers that audience. The mattress brands therefore use a factor calibrated on the mattress sites themselves, which reproduces each brand within 0.89–1.27×. Caveat: Similarweb's latest public month is August, while the panel day is 1 May. Google Trends puts mattress search interest around 1 May at 1.5–2.8× August, so moved to that day the mattress estimates roughly double (Saatva about 33K clicks a day). The headline keeps the August factor as the lower estimate.</a:t>
             </a:r>
           </a:p>
         </p:txBody>
@@ -8469,6 +8469,25 @@
                 <a:spcPct val="110000"/>
               </a:lnSpc>
               <a:spcAft>
+                <a:spcPts val="300"/>
+              </a:spcAft>
+            </a:pPr>
+            <a:r>
+              <a:rPr sz="1150" i="0" b="0">
+                <a:solidFill>
+                  <a:srgbClr val="647282"/>
+                </a:solidFill>
+                <a:latin typeface="Arial"/>
+              </a:rPr>
+              <a:t>Conservative: the Walmart-calibrated factor for the mattress brands, the population ratio for Walmart. 95% CI: Poisson sampling error of the panel count only.</a:t>
+            </a:r>
+          </a:p>
+          <a:p>
+            <a:pPr algn="l">
+              <a:lnSpc>
+                <a:spcPct val="110000"/>
+              </a:lnSpc>
+              <a:spcAft>
                 <a:spcPts val="1000"/>
               </a:spcAft>
             </a:pPr>
@@ -8479,7 +8498,7 @@
                 </a:solidFill>
                 <a:latin typeface="Arial"/>
               </a:rPr>
-              <a:t>Conservative: the Walmart-calibrated factor for the mattress brands, the population ratio for Walmart. 95% CI: Poisson sampling error of the panel count only.</a:t>
+              <a:t>Seasonality: calibrated on August traffic. Google Trends puts mattress search interest around 1 May at 1.5–2.8× August; moved to that day, mattress estimates roughly double (Saatva ~33K a day).</a:t>
             </a:r>
           </a:p>
           <a:p>
@@ -8498,7 +8517,7 @@
                 </a:solidFill>
                 <a:latin typeface="Arial"/>
               </a:rPr>
-              <a:t>Sources: Similarweb website pages (Aug 2026); DataReportal, Digital 2026 (324M US internet users); Grips Intelligence retailer pages (mattress conversion rates).</a:t>
+              <a:t>Sources: Similarweb website pages (Aug 2026); Google Trends (US, daily); DataReportal, Digital 2026 (324M US internet users); Grips Intelligence retailer pages (mattress conversion rates).</a:t>
             </a:r>
           </a:p>
         </p:txBody>

</xml_diff>

<commit_message>
Soften claims the data cannot carry
- slide 2/3: Saatva's lead rests on Similarweb; panel share is 4 of 25 visits (95% CI 6-35%),
  overlapping every rival
- slide 2/4: mattress orders labelled as assumed (benchmark conversion, none observed)
- slide 6 + README: mattress factor fit is in-sample, a fit check, not validation
- slide 9-12 + README: incrementality reads 'no sign of added orders', not 'adds no orders';
  commission at risk stated as conditional on that

Co-Authored-By: Claude Opus 5.5 <noreply@anthropic.com>
</commit_message>
<xml_diff>
--- a/deck/saatva_affiliate_analysis.pptx
+++ b/deck/saatva_affiliate_analysis.pptx
@@ -661,7 +661,7 @@
           <a:lstStyle/>
           <a:p>
             <a:r>
-              <a:t>The obvious objection to slides 8 and 9: shoppers in the cart convert at a high rate anyway, so of course these clicks convert. That is the point, and it can be tested. Take every US Walmart shopper at the moment they first view the cart, and separately the checkout. The stage is fixed before any click, and shoppers an affiliate brought to the cart are left out. Then compare those who got an affiliate click afterwards with those who did not. At the cart, 34.2% vs 31.7% order within two hours; at the checkout, 66.7% vs 75.8%. Across the 56 shoppers who got a click, 25 ordered; 25.7 would have without it. The interval is wide (ratio 0.63–1.44), so at most about 31% of these orders could be incremental, and the best estimate is none. The design favours the click, since a shopper who got one stayed on the site at least until it fired. Clicks fired at the cart carry half of Walmart's affiliate-credited orders. At an average order of $100–125 and 1–4% commission, that is $22.3M–111.3M a year paid for sales that were already happening. Saatva's panel has no orders to measure its share, so the Saatva figure is per 10% of orders hijacked: about $860 per order and 3–10% commission.</a:t>
+              <a:t>The obvious objection to slides 8 and 9: shoppers in the cart convert at a high rate anyway, so of course these clicks convert. That is the point, and it can be tested. Take every US Walmart shopper at the moment they first view the cart, and separately the checkout. The stage is fixed before any click, and shoppers an affiliate brought to the cart are left out. Then compare those who got an affiliate click afterwards with those who did not. At the cart, 34.2% vs 31.7% order within two hours; at the checkout, 66.7% vs 75.8%. Across the 56 shoppers who got a click, 25 ordered; 25.7 would have without it. The interval is wide (ratio 0.63–1.44), so at most about 31% of these orders could be incremental, and the best estimate is none. The design favours the click, since a shopper who got one stayed on the site at least until it fired. Clicks fired at the cart carry half of Walmart's affiliate-credited orders. At an average order of $100–125 and 1–4% commission, that is $22.3M–111.3M a year paid for sales that, on this evidence, were happening anyway; with 56 shoppers that is a strong lead, not proof. Saatva's panel has no orders to measure its share, so the Saatva figure is per 10% of orders hijacked: about $860 per order and 3–10% commission.</a:t>
             </a:r>
           </a:p>
         </p:txBody>
@@ -1151,7 +1151,7 @@
           <a:lstStyle/>
           <a:p>
             <a:r>
-              <a:t>Three numbers. First, 16% of Saatva's visits start with an affiliate click, against 4–11% for the other mattress brands, and Similarweb independently ranks affiliate as Saatva's #1 channel. Second, scaled to the US, that is about 16.7K affiliate clicks a day. The range is wide, 6.1K–36.4K, because it rests on six panel clicks; at category conversion rates it means roughly 84–334 orders a day. Third, where the data has volume (Walmart), the clicks that carry a hijack signal take 51–79% of the affiliate-credited orders, though they are only 26–41% of ordinary shoppers' clicks; most of the remaining click volume is click flooding by a few dozen people. Saatva's own clicks already show the same hijacking patterns. So the recommendations split in two: grow the channel, and stop paying for credit that was taken, not earned.</a:t>
+              <a:t>Three numbers. First, Similarweb ranks affiliate as Saatva's #1 channel (23.7% of traffic), and the panel points the same way: 16% of Saatva's visits start with an affiliate click, against 4–11% for the other mattress brands. That is 4 of 25 visits, so the panel alone cannot separate Saatva from its rivals; the external source carries the claim. Second, scaled to the US, that is about 16.7K affiliate clicks a day. The range is wide, 6.1K–36.4K, because it rests on six panel clicks. No mattress order followed an affiliate click in the panel day, so orders are an assumption, not a finding: at a 0.5–2% category conversion rate, roughly 84–334 a day. Third, where the data has volume (Walmart), the clicks that carry a hijack signal take 51–79% of the affiliate-credited orders, though they are only 26–41% of ordinary shoppers' clicks; most of the remaining click volume is click flooding by a few dozen people. Saatva's own clicks already show the same hijacking patterns. So the recommendations split in two: grow the channel, and stop paying for credit that was taken, not earned.</a:t>
             </a:r>
           </a:p>
         </p:txBody>
@@ -1221,7 +1221,7 @@
           <a:lstStyle/>
           <a:p>
             <a:r>
-              <a:t>The share of visits that start with an affiliate click is the most robust comparison, because it doesn't depend on scaling: Saatva 16%, Helix 10.5%, DreamCloud 7.4%, Nectar 3.9%. Nectar and DreamCloud lean on paid search instead, 43% and 37% of their visits. Similarweb agrees independently: affiliate is the #1 channel for Saatva (23.7% of traffic) and Helix (21.0%), paid search for Nectar and DreamCloud. Caveat: one day gives 19–51 visits per mattress brand, so read the order, not the decimals.</a:t>
+              <a:t>The share of visits that start with an affiliate click is the most robust comparison, because it doesn't depend on scaling: Saatva 16%, Helix 10.5%, DreamCloud 7.4%, Nectar 3.9%. Nectar and DreamCloud lean on paid search instead, 43% and 37% of their visits. Similarweb agrees independently: affiliate is the #1 channel for Saatva (23.7% of traffic) and Helix (21.0%), paid search for Nectar and DreamCloud. Caveat: one day gives 19–51 visits per mattress brand. Saatva's 16% is 4 of 25 visits, with a 95% interval of 6–35% that overlaps every rival, so the panel shows the direction and Similarweb confirms it.</a:t>
             </a:r>
           </a:p>
         </p:txBody>
@@ -1431,7 +1431,7 @@
           <a:lstStyle/>
           <a:p>
             <a:r>
-              <a:t>Validation changed the answer. 14.7% of rows were exact duplicates, and some people were recorded under two user ids, one a partial copy of the other; left as is, that inflated brand visits by 14–28% and orders by 20%. I merged ids that share three or more identical events. One pass selects the users who touched any of the five brands, so everything runs on 3.4% of the data, in about 30 seconds. Scaling: a factor calibrated on walmart.com recovers only 35–50% of the mattress sites' Similarweb traffic, because the panel under-covers that audience. The mattress brands therefore use a factor calibrated on the mattress sites themselves, which reproduces each brand within 0.89–1.27×. Caveat: Similarweb's latest public month is August, while the panel day is 1 May. Google Trends puts mattress search interest around 1 May at 1.5–2.8× August, so moved to that day the mattress estimates roughly double (Saatva about 33K clicks a day). The headline keeps the August factor as the lower estimate.</a:t>
+              <a:t>Validation changed the answer. 14.7% of rows were exact duplicates, and some people were recorded under two user ids, one a partial copy of the other; left as is, that inflated brand visits by 14–28% and orders by 20%. I merged ids that share three or more identical events. One pass selects the users who touched any of the five brands, so everything runs on 3.4% of the data, in about 30 seconds. Scaling: a factor calibrated on walmart.com recovers only 35–50% of the mattress sites' Similarweb traffic, because the panel under-covers that audience. The mattress brands therefore use a factor calibrated on the mattress sites themselves. It fits each of them within 0.89–1.27×; that is a fit check on the same figures, not an independent test. Caveat: Similarweb's latest public month is August, while the panel day is 1 May. Google Trends puts mattress search interest around 1 May at 1.5–2.8× August, so moved to that day the mattress estimates roughly double (Saatva about 33K clicks a day). The headline keeps the August factor as the lower estimate.</a:t>
             </a:r>
           </a:p>
         </p:txBody>
@@ -1571,7 +1571,7 @@
           <a:lstStyle/>
           <a:p>
             <a:r>
-              <a:t>Walmart has the volume to test the indicators. Flagged clicks are clicks without a landing, clicks fired while the shopper was already in the cart or on the site, and clicks from a publisher-bought search ad. Click-flooding clicks (next slide) are left out: they are most of the volume and almost never convert, so they would make the flagged share look smaller than it is. Among ordinary shoppers' clicks, flagged clicks are 26–41% of clicks but take 51–79% of the affiliate-credited orders, depending on how strict the look-back window is, from 2 to 30 minutes. Counted over all clicks, the same flags are 13–24%. Clicks fired after the shopper had already viewed the cart convert at 13%, against 0.4% for clicks with no signal, and the order follows a median 2.3 minutes later: these clicks close sales that were already happening. Mechanisms: 258 clicks fired from walmart.com itself a median 2 seconds after a walmart.com page, with no publisher page in between; price-comparison redirects (rd.bizrate.com, 461 flagged clicks); and coupon and cash-back extensions (Capital One Shopping, Slickdeals, Rakuten).</a:t>
+              <a:t>Walmart has the volume to test the indicators. Flagged clicks are clicks without a landing, clicks fired while the shopper was already in the cart or on the site, and clicks from a publisher-bought search ad. Click-flooding clicks (next slide) are left out: they are most of the volume and almost never convert, so they would make the flagged share look smaller than it is. Among ordinary shoppers' clicks, flagged clicks are 26–41% of clicks but take 51–79% of the affiliate-credited orders, depending on how strict the look-back window is, from 2 to 30 minutes. Counted over all clicks, the same flags are 13–24%. Clicks fired after the shopper had already viewed the cart convert at 13%, against 0.4% for clicks with no signal, and the order follows a median 2.3 minutes later: these clicks look like they close sales that were already happening. Mechanisms: 258 clicks fired from walmart.com itself a median 2 seconds after a walmart.com page, with no publisher page in between; price-comparison redirects (rd.bizrate.com, 461 flagged clicks); and coupon and cash-back extensions (Capital One Shopping, Slickdeals, Rakuten).</a:t>
             </a:r>
           </a:p>
         </p:txBody>
@@ -6896,7 +6896,7 @@
                 </a:solidFill>
                 <a:latin typeface="Arial"/>
               </a:rPr>
-              <a:t>and the next slide shows the click adds no orders</a:t>
+              <a:t>and the next slide finds no sign it adds orders</a:t>
             </a:r>
           </a:p>
         </p:txBody>
@@ -7253,7 +7253,7 @@
                 </a:solidFill>
                 <a:latin typeface="Georgia"/>
               </a:rPr>
-              <a:t>A click fired at the cart adds no orders</a:t>
+              <a:t>No sign that a click fired at the cart adds orders</a:t>
             </a:r>
           </a:p>
         </p:txBody>
@@ -8403,7 +8403,7 @@
                 </a:solidFill>
                 <a:latin typeface="Arial"/>
               </a:rPr>
-              <a:t>a year at Walmart (half its affiliate orders)</a:t>
+              <a:t>a year at Walmart, if they add no orders</a:t>
             </a:r>
           </a:p>
         </p:txBody>
@@ -10807,7 +10807,7 @@
                 </a:solidFill>
                 <a:latin typeface="Arial"/>
               </a:rPr>
-              <a:t>Cart-stage clicks add no orders (slide 10); plus extension stand-down, PPC policy</a:t>
+              <a:t>Cart-stage clicks show no added orders (slide 10); plus extension stand-down, PPC policy</a:t>
             </a:r>
           </a:p>
         </p:txBody>
@@ -18909,7 +18909,7 @@
                 </a:solidFill>
                 <a:latin typeface="Georgia"/>
               </a:rPr>
-              <a:t>Affiliate is Saatva's edge; quality is the next lever</a:t>
+              <a:t>Affiliate is Saatva's #1 channel; quality is the next lever</a:t>
             </a:r>
           </a:p>
         </p:txBody>
@@ -19277,7 +19277,7 @@
                 </a:solidFill>
                 <a:latin typeface="Arial"/>
               </a:rPr>
-              <a:t>Rivals: 4–11%</a:t>
+              <a:t>Rivals: 4–11%  ·  Similarweb: #1</a:t>
             </a:r>
           </a:p>
         </p:txBody>
@@ -19503,7 +19503,7 @@
                 </a:solidFill>
                 <a:latin typeface="Arial"/>
               </a:rPr>
-              <a:t>Range 6.1K–36.4K  ·  84–334 orders a day</a:t>
+              <a:t>Range 6.1K–36.4K  ·  84–334 orders a day, assumed</a:t>
             </a:r>
           </a:p>
         </p:txBody>
@@ -20507,7 +20507,7 @@
                 </a:solidFill>
                 <a:latin typeface="Georgia"/>
               </a:rPr>
-              <a:t>Affiliate drives 16% of Saatva's visits, the top share</a:t>
+              <a:t>Saatva leans on affiliate more than its rivals</a:t>
             </a:r>
           </a:p>
         </p:txBody>
@@ -20817,7 +20817,7 @@
                 </a:solidFill>
                 <a:latin typeface="Arial"/>
               </a:rPr>
-              <a:t>25 visits</a:t>
+              <a:t>4 of 25 visits</a:t>
             </a:r>
           </a:p>
         </p:txBody>
@@ -21024,7 +21024,7 @@
                 </a:solidFill>
                 <a:latin typeface="Arial"/>
               </a:rPr>
-              <a:t>19 visits</a:t>
+              <a:t>2 of 19 visits</a:t>
             </a:r>
           </a:p>
         </p:txBody>
@@ -21231,7 +21231,7 @@
                 </a:solidFill>
                 <a:latin typeface="Arial"/>
               </a:rPr>
-              <a:t>27 visits</a:t>
+              <a:t>2 of 27 visits</a:t>
             </a:r>
           </a:p>
         </p:txBody>
@@ -21440,7 +21440,7 @@
                 </a:solidFill>
                 <a:latin typeface="Arial"/>
               </a:rPr>
-              <a:t>51 visits</a:t>
+              <a:t>2 of 51 visits</a:t>
             </a:r>
           </a:p>
         </p:txBody>
@@ -21786,7 +21786,7 @@
                 </a:solidFill>
                 <a:latin typeface="Arial"/>
               </a:rPr>
-              <a:t>US panel visits, 1 May 2026. Nectar and DreamCloud lean on paid search: 43% and 37% of their visits.</a:t>
+              <a:t>US panel visits, 1 May 2026. Nectar and DreamCloud lean on paid search: 43% and 37% of their visits. Small counts: the 95% intervals overlap (Saatva 6–35%), so the ranking rests on Similarweb.</a:t>
             </a:r>
           </a:p>
         </p:txBody>
@@ -22429,7 +22429,7 @@
                 </a:solidFill>
                 <a:latin typeface="Arial"/>
               </a:rPr>
-              <a:t>Orders a day (est.)</a:t>
+              <a:t>Orders a day (assumed)</a:t>
             </a:r>
           </a:p>
         </p:txBody>
@@ -23215,7 +23215,7 @@
                 </a:solidFill>
                 <a:latin typeface="Arial"/>
               </a:rPr>
-              <a:t>At a 0.5–2% category conversion rate</a:t>
+              <a:t>Not observed: 0.5–2% category conversion applied to the clicks</a:t>
             </a:r>
           </a:p>
         </p:txBody>
@@ -26731,7 +26731,7 @@
                 </a:solidFill>
                 <a:latin typeface="Arial"/>
               </a:rPr>
-              <a:t>The mattress factor matches each site within </a:t>
+              <a:t>The mattress factor fits each site within </a:t>
             </a:r>
             <a:r>
               <a:rPr sz="1300" i="0" b="1">
@@ -26749,7 +26749,7 @@
                 </a:solidFill>
                 <a:latin typeface="Arial"/>
               </a:rPr>
-              <a:t>.</a:t>
+              <a:t> (calibrated on the same sites, so a fit check).</a:t>
             </a:r>
           </a:p>
         </p:txBody>

</xml_diff>